<commit_message>
20260626 commit : finished, today
</commit_message>
<xml_diff>
--- a/ppt/UI.pptx
+++ b/ppt/UI.pptx
@@ -7,6 +7,7 @@
   <p:sldIdLst>
     <p:sldId id="256" r:id="rId2"/>
     <p:sldId id="257" r:id="rId3"/>
+    <p:sldId id="258" r:id="rId4"/>
   </p:sldIdLst>
   <p:sldSz cx="12192000" cy="6858000"/>
   <p:notesSz cx="6858000" cy="9144000"/>
@@ -105,6 +106,11 @@
       </a:defRPr>
     </a:lvl9pPr>
   </p:defaultTextStyle>
+  <p:extLst>
+    <p:ext uri="{EFAFB233-063F-42B5-8137-9DF3F51BA10A}">
+      <p15:sldGuideLst xmlns:p15="http://schemas.microsoft.com/office/powerpoint/2012/main"/>
+    </p:ext>
+  </p:extLst>
 </p:presentation>
 </file>
 
@@ -239,7 +245,7 @@
           <a:p>
             <a:fld id="{7D6D5DB7-34A5-4DF0-94A0-9851E520DD60}" type="datetimeFigureOut">
               <a:rPr lang="ko-KR" altLang="en-US" smtClean="0"/>
-              <a:t>2026-06-25</a:t>
+              <a:t>2026-06-26</a:t>
             </a:fld>
             <a:endParaRPr lang="ko-KR" altLang="en-US"/>
           </a:p>
@@ -409,7 +415,7 @@
           <a:p>
             <a:fld id="{7D6D5DB7-34A5-4DF0-94A0-9851E520DD60}" type="datetimeFigureOut">
               <a:rPr lang="ko-KR" altLang="en-US" smtClean="0"/>
-              <a:t>2026-06-25</a:t>
+              <a:t>2026-06-26</a:t>
             </a:fld>
             <a:endParaRPr lang="ko-KR" altLang="en-US"/>
           </a:p>
@@ -589,7 +595,7 @@
           <a:p>
             <a:fld id="{7D6D5DB7-34A5-4DF0-94A0-9851E520DD60}" type="datetimeFigureOut">
               <a:rPr lang="ko-KR" altLang="en-US" smtClean="0"/>
-              <a:t>2026-06-25</a:t>
+              <a:t>2026-06-26</a:t>
             </a:fld>
             <a:endParaRPr lang="ko-KR" altLang="en-US"/>
           </a:p>
@@ -759,7 +765,7 @@
           <a:p>
             <a:fld id="{7D6D5DB7-34A5-4DF0-94A0-9851E520DD60}" type="datetimeFigureOut">
               <a:rPr lang="ko-KR" altLang="en-US" smtClean="0"/>
-              <a:t>2026-06-25</a:t>
+              <a:t>2026-06-26</a:t>
             </a:fld>
             <a:endParaRPr lang="ko-KR" altLang="en-US"/>
           </a:p>
@@ -1005,7 +1011,7 @@
           <a:p>
             <a:fld id="{7D6D5DB7-34A5-4DF0-94A0-9851E520DD60}" type="datetimeFigureOut">
               <a:rPr lang="ko-KR" altLang="en-US" smtClean="0"/>
-              <a:t>2026-06-25</a:t>
+              <a:t>2026-06-26</a:t>
             </a:fld>
             <a:endParaRPr lang="ko-KR" altLang="en-US"/>
           </a:p>
@@ -1237,7 +1243,7 @@
           <a:p>
             <a:fld id="{7D6D5DB7-34A5-4DF0-94A0-9851E520DD60}" type="datetimeFigureOut">
               <a:rPr lang="ko-KR" altLang="en-US" smtClean="0"/>
-              <a:t>2026-06-25</a:t>
+              <a:t>2026-06-26</a:t>
             </a:fld>
             <a:endParaRPr lang="ko-KR" altLang="en-US"/>
           </a:p>
@@ -1604,7 +1610,7 @@
           <a:p>
             <a:fld id="{7D6D5DB7-34A5-4DF0-94A0-9851E520DD60}" type="datetimeFigureOut">
               <a:rPr lang="ko-KR" altLang="en-US" smtClean="0"/>
-              <a:t>2026-06-25</a:t>
+              <a:t>2026-06-26</a:t>
             </a:fld>
             <a:endParaRPr lang="ko-KR" altLang="en-US"/>
           </a:p>
@@ -1722,7 +1728,7 @@
           <a:p>
             <a:fld id="{7D6D5DB7-34A5-4DF0-94A0-9851E520DD60}" type="datetimeFigureOut">
               <a:rPr lang="ko-KR" altLang="en-US" smtClean="0"/>
-              <a:t>2026-06-25</a:t>
+              <a:t>2026-06-26</a:t>
             </a:fld>
             <a:endParaRPr lang="ko-KR" altLang="en-US"/>
           </a:p>
@@ -1817,7 +1823,7 @@
           <a:p>
             <a:fld id="{7D6D5DB7-34A5-4DF0-94A0-9851E520DD60}" type="datetimeFigureOut">
               <a:rPr lang="ko-KR" altLang="en-US" smtClean="0"/>
-              <a:t>2026-06-25</a:t>
+              <a:t>2026-06-26</a:t>
             </a:fld>
             <a:endParaRPr lang="ko-KR" altLang="en-US"/>
           </a:p>
@@ -2094,7 +2100,7 @@
           <a:p>
             <a:fld id="{7D6D5DB7-34A5-4DF0-94A0-9851E520DD60}" type="datetimeFigureOut">
               <a:rPr lang="ko-KR" altLang="en-US" smtClean="0"/>
-              <a:t>2026-06-25</a:t>
+              <a:t>2026-06-26</a:t>
             </a:fld>
             <a:endParaRPr lang="ko-KR" altLang="en-US"/>
           </a:p>
@@ -2347,7 +2353,7 @@
           <a:p>
             <a:fld id="{7D6D5DB7-34A5-4DF0-94A0-9851E520DD60}" type="datetimeFigureOut">
               <a:rPr lang="ko-KR" altLang="en-US" smtClean="0"/>
-              <a:t>2026-06-25</a:t>
+              <a:t>2026-06-26</a:t>
             </a:fld>
             <a:endParaRPr lang="ko-KR" altLang="en-US"/>
           </a:p>
@@ -2560,7 +2566,7 @@
           <a:p>
             <a:fld id="{7D6D5DB7-34A5-4DF0-94A0-9851E520DD60}" type="datetimeFigureOut">
               <a:rPr lang="ko-KR" altLang="en-US" smtClean="0"/>
-              <a:t>2026-06-25</a:t>
+              <a:t>2026-06-26</a:t>
             </a:fld>
             <a:endParaRPr lang="ko-KR" altLang="en-US"/>
           </a:p>
@@ -2967,7 +2973,7 @@
       </p:grpSpPr>
       <p:grpSp>
         <p:nvGrpSpPr>
-          <p:cNvPr id="16" name="그룹 15"/>
+          <p:cNvPr id="2" name="그룹 1"/>
           <p:cNvGrpSpPr/>
           <p:nvPr/>
         </p:nvGrpSpPr>
@@ -2975,7 +2981,7 @@
           <a:xfrm>
             <a:off x="409575" y="866775"/>
             <a:ext cx="10810875" cy="5391150"/>
-            <a:chOff x="1171575" y="1057275"/>
+            <a:chOff x="409575" y="866775"/>
             <a:chExt cx="10810875" cy="5391150"/>
           </a:xfrm>
         </p:grpSpPr>
@@ -2987,7 +2993,7 @@
           </p:nvSpPr>
           <p:spPr>
             <a:xfrm>
-              <a:off x="1171575" y="1057275"/>
+              <a:off x="409575" y="866775"/>
               <a:ext cx="10810875" cy="5391150"/>
             </a:xfrm>
             <a:prstGeom prst="rect">
@@ -3030,7 +3036,7 @@
           </p:nvSpPr>
           <p:spPr>
             <a:xfrm>
-              <a:off x="1333500" y="1481137"/>
+              <a:off x="571500" y="1290637"/>
               <a:ext cx="7620000" cy="4810125"/>
             </a:xfrm>
             <a:prstGeom prst="rect">
@@ -3070,48 +3076,8 @@
           </p:nvSpPr>
           <p:spPr>
             <a:xfrm>
-              <a:off x="9134475" y="1481138"/>
-              <a:ext cx="2695575" cy="3309938"/>
-            </a:xfrm>
-            <a:prstGeom prst="rect">
-              <a:avLst/>
-            </a:prstGeom>
-          </p:spPr>
-          <p:style>
-            <a:lnRef idx="2">
-              <a:schemeClr val="accent1">
-                <a:shade val="50000"/>
-              </a:schemeClr>
-            </a:lnRef>
-            <a:fillRef idx="1">
-              <a:schemeClr val="accent1"/>
-            </a:fillRef>
-            <a:effectRef idx="0">
-              <a:schemeClr val="accent1"/>
-            </a:effectRef>
-            <a:fontRef idx="minor">
-              <a:schemeClr val="lt1"/>
-            </a:fontRef>
-          </p:style>
-          <p:txBody>
-            <a:bodyPr rtlCol="0" anchor="ctr"/>
-            <a:lstStyle/>
-            <a:p>
-              <a:pPr algn="ctr"/>
-              <a:endParaRPr lang="ko-KR" altLang="en-US"/>
-            </a:p>
-          </p:txBody>
-        </p:sp>
-        <p:sp>
-          <p:nvSpPr>
-            <p:cNvPr id="6" name="직사각형 5"/>
-            <p:cNvSpPr/>
-            <p:nvPr/>
-          </p:nvSpPr>
-          <p:spPr>
-            <a:xfrm>
-              <a:off x="9134475" y="4953000"/>
-              <a:ext cx="2695575" cy="1338262"/>
+              <a:off x="8372475" y="1290638"/>
+              <a:ext cx="2695575" cy="2543425"/>
             </a:xfrm>
             <a:prstGeom prst="rect">
               <a:avLst/>
@@ -3150,7 +3116,7 @@
           </p:nvSpPr>
           <p:spPr>
             <a:xfrm>
-              <a:off x="1333500" y="1162050"/>
+              <a:off x="571500" y="971550"/>
               <a:ext cx="1028700" cy="234007"/>
             </a:xfrm>
             <a:prstGeom prst="rect">
@@ -3190,7 +3156,7 @@
           </p:nvSpPr>
           <p:spPr>
             <a:xfrm>
-              <a:off x="2466975" y="1162050"/>
+              <a:off x="1704975" y="971550"/>
               <a:ext cx="1028700" cy="234007"/>
             </a:xfrm>
             <a:prstGeom prst="rect">
@@ -3230,7 +3196,7 @@
           </p:nvSpPr>
           <p:spPr>
             <a:xfrm>
-              <a:off x="11539537" y="1162050"/>
+              <a:off x="10777537" y="971550"/>
               <a:ext cx="280988" cy="235743"/>
             </a:xfrm>
             <a:prstGeom prst="rect">
@@ -3270,7 +3236,7 @@
           </p:nvSpPr>
           <p:spPr>
             <a:xfrm>
-              <a:off x="11139487" y="1162050"/>
+              <a:off x="10377487" y="971550"/>
               <a:ext cx="280988" cy="235743"/>
             </a:xfrm>
             <a:prstGeom prst="rect">
@@ -3310,7 +3276,7 @@
           </p:nvSpPr>
           <p:spPr>
             <a:xfrm>
-              <a:off x="3600450" y="1162050"/>
+              <a:off x="2838450" y="971550"/>
               <a:ext cx="1028700" cy="234007"/>
             </a:xfrm>
             <a:prstGeom prst="rect">
@@ -3350,7 +3316,7 @@
           </p:nvSpPr>
           <p:spPr>
             <a:xfrm>
-              <a:off x="4733925" y="1162050"/>
+              <a:off x="3971925" y="971550"/>
               <a:ext cx="1028700" cy="234007"/>
             </a:xfrm>
             <a:prstGeom prst="rect">
@@ -3382,17 +3348,291 @@
             </a:p>
           </p:txBody>
         </p:sp>
+        <p:sp>
+          <p:nvSpPr>
+            <p:cNvPr id="17" name="직사각형 16"/>
+            <p:cNvSpPr/>
+            <p:nvPr/>
+          </p:nvSpPr>
+          <p:spPr>
+            <a:xfrm>
+              <a:off x="8515350" y="1450181"/>
+              <a:ext cx="2438400" cy="867133"/>
+            </a:xfrm>
+            <a:prstGeom prst="rect">
+              <a:avLst/>
+            </a:prstGeom>
+            <a:solidFill>
+              <a:schemeClr val="accent2">
+                <a:lumMod val="60000"/>
+                <a:lumOff val="40000"/>
+              </a:schemeClr>
+            </a:solidFill>
+          </p:spPr>
+          <p:style>
+            <a:lnRef idx="2">
+              <a:schemeClr val="accent1">
+                <a:shade val="50000"/>
+              </a:schemeClr>
+            </a:lnRef>
+            <a:fillRef idx="1">
+              <a:schemeClr val="accent1"/>
+            </a:fillRef>
+            <a:effectRef idx="0">
+              <a:schemeClr val="accent1"/>
+            </a:effectRef>
+            <a:fontRef idx="minor">
+              <a:schemeClr val="lt1"/>
+            </a:fontRef>
+          </p:style>
+          <p:txBody>
+            <a:bodyPr rtlCol="0" anchor="ctr"/>
+            <a:lstStyle/>
+            <a:p>
+              <a:pPr algn="ctr"/>
+              <a:r>
+                <a:rPr lang="en-US" altLang="ko-KR" dirty="0" smtClean="0"/>
+                <a:t>NEW</a:t>
+              </a:r>
+              <a:endParaRPr lang="ko-KR" altLang="en-US" dirty="0"/>
+            </a:p>
+          </p:txBody>
+        </p:sp>
+        <p:sp>
+          <p:nvSpPr>
+            <p:cNvPr id="18" name="직사각형 17"/>
+            <p:cNvSpPr/>
+            <p:nvPr/>
+          </p:nvSpPr>
+          <p:spPr>
+            <a:xfrm>
+              <a:off x="8515350" y="2476857"/>
+              <a:ext cx="2438400" cy="867133"/>
+            </a:xfrm>
+            <a:prstGeom prst="rect">
+              <a:avLst/>
+            </a:prstGeom>
+            <a:solidFill>
+              <a:schemeClr val="tx2">
+                <a:lumMod val="20000"/>
+                <a:lumOff val="80000"/>
+              </a:schemeClr>
+            </a:solidFill>
+          </p:spPr>
+          <p:style>
+            <a:lnRef idx="2">
+              <a:schemeClr val="accent1">
+                <a:shade val="50000"/>
+              </a:schemeClr>
+            </a:lnRef>
+            <a:fillRef idx="1">
+              <a:schemeClr val="accent1"/>
+            </a:fillRef>
+            <a:effectRef idx="0">
+              <a:schemeClr val="accent1"/>
+            </a:effectRef>
+            <a:fontRef idx="minor">
+              <a:schemeClr val="lt1"/>
+            </a:fontRef>
+          </p:style>
+          <p:txBody>
+            <a:bodyPr rtlCol="0" anchor="ctr"/>
+            <a:lstStyle/>
+            <a:p>
+              <a:pPr algn="ctr"/>
+              <a:endParaRPr lang="ko-KR" altLang="en-US"/>
+            </a:p>
+          </p:txBody>
+        </p:sp>
       </p:grpSp>
       <p:sp>
         <p:nvSpPr>
-          <p:cNvPr id="17" name="직사각형 16"/>
+          <p:cNvPr id="20" name="직사각형 19"/>
           <p:cNvSpPr/>
           <p:nvPr/>
         </p:nvSpPr>
         <p:spPr>
           <a:xfrm>
-            <a:off x="8515350" y="1450182"/>
-            <a:ext cx="2438400" cy="464344"/>
+            <a:off x="8386762" y="3993606"/>
+            <a:ext cx="2695575" cy="2099475"/>
+          </a:xfrm>
+          <a:prstGeom prst="rect">
+            <a:avLst/>
+          </a:prstGeom>
+        </p:spPr>
+        <p:style>
+          <a:lnRef idx="2">
+            <a:schemeClr val="accent1">
+              <a:shade val="50000"/>
+            </a:schemeClr>
+          </a:lnRef>
+          <a:fillRef idx="1">
+            <a:schemeClr val="accent1"/>
+          </a:fillRef>
+          <a:effectRef idx="0">
+            <a:schemeClr val="accent1"/>
+          </a:effectRef>
+          <a:fontRef idx="minor">
+            <a:schemeClr val="lt1"/>
+          </a:fontRef>
+        </p:style>
+        <p:txBody>
+          <a:bodyPr rtlCol="0" anchor="ctr"/>
+          <a:lstStyle/>
+          <a:p>
+            <a:pPr algn="ctr"/>
+            <a:endParaRPr lang="ko-KR" altLang="en-US"/>
+          </a:p>
+        </p:txBody>
+      </p:sp>
+      <p:sp>
+        <p:nvSpPr>
+          <p:cNvPr id="21" name="직사각형 20"/>
+          <p:cNvSpPr/>
+          <p:nvPr/>
+        </p:nvSpPr>
+        <p:spPr>
+          <a:xfrm>
+            <a:off x="8515350" y="4176211"/>
+            <a:ext cx="2438400" cy="395790"/>
+          </a:xfrm>
+          <a:prstGeom prst="rect">
+            <a:avLst/>
+          </a:prstGeom>
+          <a:solidFill>
+            <a:schemeClr val="tx2">
+              <a:lumMod val="20000"/>
+              <a:lumOff val="80000"/>
+            </a:schemeClr>
+          </a:solidFill>
+        </p:spPr>
+        <p:style>
+          <a:lnRef idx="2">
+            <a:schemeClr val="accent1">
+              <a:shade val="50000"/>
+            </a:schemeClr>
+          </a:lnRef>
+          <a:fillRef idx="1">
+            <a:schemeClr val="accent1"/>
+          </a:fillRef>
+          <a:effectRef idx="0">
+            <a:schemeClr val="accent1"/>
+          </a:effectRef>
+          <a:fontRef idx="minor">
+            <a:schemeClr val="lt1"/>
+          </a:fontRef>
+        </p:style>
+        <p:txBody>
+          <a:bodyPr rtlCol="0" anchor="ctr"/>
+          <a:lstStyle/>
+          <a:p>
+            <a:pPr algn="ctr"/>
+            <a:endParaRPr lang="ko-KR" altLang="en-US"/>
+          </a:p>
+        </p:txBody>
+      </p:sp>
+      <p:sp>
+        <p:nvSpPr>
+          <p:cNvPr id="22" name="직사각형 21"/>
+          <p:cNvSpPr/>
+          <p:nvPr/>
+        </p:nvSpPr>
+        <p:spPr>
+          <a:xfrm>
+            <a:off x="8515350" y="4679638"/>
+            <a:ext cx="2438400" cy="395790"/>
+          </a:xfrm>
+          <a:prstGeom prst="rect">
+            <a:avLst/>
+          </a:prstGeom>
+          <a:solidFill>
+            <a:schemeClr val="tx2">
+              <a:lumMod val="20000"/>
+              <a:lumOff val="80000"/>
+            </a:schemeClr>
+          </a:solidFill>
+        </p:spPr>
+        <p:style>
+          <a:lnRef idx="2">
+            <a:schemeClr val="accent1">
+              <a:shade val="50000"/>
+            </a:schemeClr>
+          </a:lnRef>
+          <a:fillRef idx="1">
+            <a:schemeClr val="accent1"/>
+          </a:fillRef>
+          <a:effectRef idx="0">
+            <a:schemeClr val="accent1"/>
+          </a:effectRef>
+          <a:fontRef idx="minor">
+            <a:schemeClr val="lt1"/>
+          </a:fontRef>
+        </p:style>
+        <p:txBody>
+          <a:bodyPr rtlCol="0" anchor="ctr"/>
+          <a:lstStyle/>
+          <a:p>
+            <a:pPr algn="ctr"/>
+            <a:endParaRPr lang="ko-KR" altLang="en-US"/>
+          </a:p>
+        </p:txBody>
+      </p:sp>
+      <p:sp>
+        <p:nvSpPr>
+          <p:cNvPr id="23" name="직사각형 22"/>
+          <p:cNvSpPr/>
+          <p:nvPr/>
+        </p:nvSpPr>
+        <p:spPr>
+          <a:xfrm>
+            <a:off x="8515350" y="5183065"/>
+            <a:ext cx="2438400" cy="395790"/>
+          </a:xfrm>
+          <a:prstGeom prst="rect">
+            <a:avLst/>
+          </a:prstGeom>
+          <a:solidFill>
+            <a:schemeClr val="tx2">
+              <a:lumMod val="20000"/>
+              <a:lumOff val="80000"/>
+            </a:schemeClr>
+          </a:solidFill>
+        </p:spPr>
+        <p:style>
+          <a:lnRef idx="2">
+            <a:schemeClr val="accent1">
+              <a:shade val="50000"/>
+            </a:schemeClr>
+          </a:lnRef>
+          <a:fillRef idx="1">
+            <a:schemeClr val="accent1"/>
+          </a:fillRef>
+          <a:effectRef idx="0">
+            <a:schemeClr val="accent1"/>
+          </a:effectRef>
+          <a:fontRef idx="minor">
+            <a:schemeClr val="lt1"/>
+          </a:fontRef>
+        </p:style>
+        <p:txBody>
+          <a:bodyPr rtlCol="0" anchor="ctr"/>
+          <a:lstStyle/>
+          <a:p>
+            <a:pPr algn="ctr"/>
+            <a:endParaRPr lang="ko-KR" altLang="en-US"/>
+          </a:p>
+        </p:txBody>
+      </p:sp>
+      <p:sp>
+        <p:nvSpPr>
+          <p:cNvPr id="24" name="직사각형 23"/>
+          <p:cNvSpPr/>
+          <p:nvPr/>
+        </p:nvSpPr>
+        <p:spPr>
+          <a:xfrm>
+            <a:off x="8515350" y="5697291"/>
+            <a:ext cx="2438400" cy="238288"/>
           </a:xfrm>
           <a:prstGeom prst="rect">
             <a:avLst/>
@@ -3622,10 +3862,479 @@
           </a:p>
         </p:txBody>
       </p:sp>
+      <p:sp>
+        <p:nvSpPr>
+          <p:cNvPr id="6" name="직사각형 5"/>
+          <p:cNvSpPr/>
+          <p:nvPr/>
+        </p:nvSpPr>
+        <p:spPr>
+          <a:xfrm>
+            <a:off x="718887" y="1451219"/>
+            <a:ext cx="10125576" cy="395790"/>
+          </a:xfrm>
+          <a:prstGeom prst="rect">
+            <a:avLst/>
+          </a:prstGeom>
+          <a:solidFill>
+            <a:schemeClr val="tx2">
+              <a:lumMod val="20000"/>
+              <a:lumOff val="80000"/>
+            </a:schemeClr>
+          </a:solidFill>
+        </p:spPr>
+        <p:style>
+          <a:lnRef idx="2">
+            <a:schemeClr val="accent1">
+              <a:shade val="50000"/>
+            </a:schemeClr>
+          </a:lnRef>
+          <a:fillRef idx="1">
+            <a:schemeClr val="accent1"/>
+          </a:fillRef>
+          <a:effectRef idx="0">
+            <a:schemeClr val="accent1"/>
+          </a:effectRef>
+          <a:fontRef idx="minor">
+            <a:schemeClr val="lt1"/>
+          </a:fontRef>
+        </p:style>
+        <p:txBody>
+          <a:bodyPr rtlCol="0" anchor="ctr"/>
+          <a:lstStyle/>
+          <a:p>
+            <a:pPr algn="ctr"/>
+            <a:endParaRPr lang="ko-KR" altLang="en-US"/>
+          </a:p>
+        </p:txBody>
+      </p:sp>
+      <p:sp>
+        <p:nvSpPr>
+          <p:cNvPr id="9" name="직사각형 8"/>
+          <p:cNvSpPr/>
+          <p:nvPr/>
+        </p:nvSpPr>
+        <p:spPr>
+          <a:xfrm>
+            <a:off x="718887" y="1987896"/>
+            <a:ext cx="10125576" cy="395790"/>
+          </a:xfrm>
+          <a:prstGeom prst="rect">
+            <a:avLst/>
+          </a:prstGeom>
+          <a:solidFill>
+            <a:schemeClr val="tx2">
+              <a:lumMod val="20000"/>
+              <a:lumOff val="80000"/>
+            </a:schemeClr>
+          </a:solidFill>
+        </p:spPr>
+        <p:style>
+          <a:lnRef idx="2">
+            <a:schemeClr val="accent1">
+              <a:shade val="50000"/>
+            </a:schemeClr>
+          </a:lnRef>
+          <a:fillRef idx="1">
+            <a:schemeClr val="accent1"/>
+          </a:fillRef>
+          <a:effectRef idx="0">
+            <a:schemeClr val="accent1"/>
+          </a:effectRef>
+          <a:fontRef idx="minor">
+            <a:schemeClr val="lt1"/>
+          </a:fontRef>
+        </p:style>
+        <p:txBody>
+          <a:bodyPr rtlCol="0" anchor="ctr"/>
+          <a:lstStyle/>
+          <a:p>
+            <a:pPr algn="ctr"/>
+            <a:endParaRPr lang="ko-KR" altLang="en-US"/>
+          </a:p>
+        </p:txBody>
+      </p:sp>
+      <p:sp>
+        <p:nvSpPr>
+          <p:cNvPr id="10" name="직사각형 9"/>
+          <p:cNvSpPr/>
+          <p:nvPr/>
+        </p:nvSpPr>
+        <p:spPr>
+          <a:xfrm>
+            <a:off x="718887" y="2522478"/>
+            <a:ext cx="10125576" cy="395790"/>
+          </a:xfrm>
+          <a:prstGeom prst="rect">
+            <a:avLst/>
+          </a:prstGeom>
+          <a:solidFill>
+            <a:schemeClr val="tx2">
+              <a:lumMod val="20000"/>
+              <a:lumOff val="80000"/>
+            </a:schemeClr>
+          </a:solidFill>
+        </p:spPr>
+        <p:style>
+          <a:lnRef idx="2">
+            <a:schemeClr val="accent1">
+              <a:shade val="50000"/>
+            </a:schemeClr>
+          </a:lnRef>
+          <a:fillRef idx="1">
+            <a:schemeClr val="accent1"/>
+          </a:fillRef>
+          <a:effectRef idx="0">
+            <a:schemeClr val="accent1"/>
+          </a:effectRef>
+          <a:fontRef idx="minor">
+            <a:schemeClr val="lt1"/>
+          </a:fontRef>
+        </p:style>
+        <p:txBody>
+          <a:bodyPr rtlCol="0" anchor="ctr"/>
+          <a:lstStyle/>
+          <a:p>
+            <a:pPr algn="ctr"/>
+            <a:endParaRPr lang="ko-KR" altLang="en-US"/>
+          </a:p>
+        </p:txBody>
+      </p:sp>
+      <p:sp>
+        <p:nvSpPr>
+          <p:cNvPr id="11" name="직사각형 10"/>
+          <p:cNvSpPr/>
+          <p:nvPr/>
+        </p:nvSpPr>
+        <p:spPr>
+          <a:xfrm>
+            <a:off x="718887" y="3057060"/>
+            <a:ext cx="10125576" cy="1338477"/>
+          </a:xfrm>
+          <a:prstGeom prst="rect">
+            <a:avLst/>
+          </a:prstGeom>
+          <a:solidFill>
+            <a:schemeClr val="tx2">
+              <a:lumMod val="20000"/>
+              <a:lumOff val="80000"/>
+            </a:schemeClr>
+          </a:solidFill>
+        </p:spPr>
+        <p:style>
+          <a:lnRef idx="2">
+            <a:schemeClr val="accent1">
+              <a:shade val="50000"/>
+            </a:schemeClr>
+          </a:lnRef>
+          <a:fillRef idx="1">
+            <a:schemeClr val="accent1"/>
+          </a:fillRef>
+          <a:effectRef idx="0">
+            <a:schemeClr val="accent1"/>
+          </a:effectRef>
+          <a:fontRef idx="minor">
+            <a:schemeClr val="lt1"/>
+          </a:fontRef>
+        </p:style>
+        <p:txBody>
+          <a:bodyPr rtlCol="0" anchor="ctr"/>
+          <a:lstStyle/>
+          <a:p>
+            <a:pPr algn="ctr"/>
+            <a:endParaRPr lang="ko-KR" altLang="en-US"/>
+          </a:p>
+        </p:txBody>
+      </p:sp>
     </p:spTree>
     <p:extLst>
       <p:ext uri="{BB962C8B-B14F-4D97-AF65-F5344CB8AC3E}">
         <p14:creationId xmlns:p14="http://schemas.microsoft.com/office/powerpoint/2010/main" val="589975460"/>
+      </p:ext>
+    </p:extLst>
+  </p:cSld>
+  <p:clrMapOvr>
+    <a:masterClrMapping/>
+  </p:clrMapOvr>
+</p:sld>
+</file>
+
+<file path=ppt/slides/slide3.xml><?xml version="1.0" encoding="utf-8"?>
+<p:sld xmlns:a="http://schemas.openxmlformats.org/drawingml/2006/main" xmlns:r="http://schemas.openxmlformats.org/officeDocument/2006/relationships" xmlns:p="http://schemas.openxmlformats.org/presentationml/2006/main">
+  <p:cSld>
+    <p:spTree>
+      <p:nvGrpSpPr>
+        <p:cNvPr id="1" name=""/>
+        <p:cNvGrpSpPr/>
+        <p:nvPr/>
+      </p:nvGrpSpPr>
+      <p:grpSpPr>
+        <a:xfrm>
+          <a:off x="0" y="0"/>
+          <a:ext cx="0" cy="0"/>
+          <a:chOff x="0" y="0"/>
+          <a:chExt cx="0" cy="0"/>
+        </a:xfrm>
+      </p:grpSpPr>
+      <p:sp>
+        <p:nvSpPr>
+          <p:cNvPr id="12" name="직사각형 11"/>
+          <p:cNvSpPr/>
+          <p:nvPr/>
+        </p:nvSpPr>
+        <p:spPr>
+          <a:xfrm>
+            <a:off x="409575" y="866775"/>
+            <a:ext cx="10810875" cy="5391150"/>
+          </a:xfrm>
+          <a:prstGeom prst="rect">
+            <a:avLst/>
+          </a:prstGeom>
+          <a:solidFill>
+            <a:schemeClr val="bg2"/>
+          </a:solidFill>
+        </p:spPr>
+        <p:style>
+          <a:lnRef idx="2">
+            <a:schemeClr val="accent1">
+              <a:shade val="50000"/>
+            </a:schemeClr>
+          </a:lnRef>
+          <a:fillRef idx="1">
+            <a:schemeClr val="accent1"/>
+          </a:fillRef>
+          <a:effectRef idx="0">
+            <a:schemeClr val="accent1"/>
+          </a:effectRef>
+          <a:fontRef idx="minor">
+            <a:schemeClr val="lt1"/>
+          </a:fontRef>
+        </p:style>
+        <p:txBody>
+          <a:bodyPr rtlCol="0" anchor="ctr"/>
+          <a:lstStyle/>
+          <a:p>
+            <a:pPr algn="ctr"/>
+            <a:endParaRPr lang="ko-KR" altLang="en-US"/>
+          </a:p>
+        </p:txBody>
+      </p:sp>
+      <p:sp>
+        <p:nvSpPr>
+          <p:cNvPr id="7" name="직사각형 6"/>
+          <p:cNvSpPr/>
+          <p:nvPr/>
+        </p:nvSpPr>
+        <p:spPr>
+          <a:xfrm>
+            <a:off x="571500" y="971550"/>
+            <a:ext cx="1028700" cy="234007"/>
+          </a:xfrm>
+          <a:prstGeom prst="rect">
+            <a:avLst/>
+          </a:prstGeom>
+        </p:spPr>
+        <p:style>
+          <a:lnRef idx="2">
+            <a:schemeClr val="accent1">
+              <a:shade val="50000"/>
+            </a:schemeClr>
+          </a:lnRef>
+          <a:fillRef idx="1">
+            <a:schemeClr val="accent1"/>
+          </a:fillRef>
+          <a:effectRef idx="0">
+            <a:schemeClr val="accent1"/>
+          </a:effectRef>
+          <a:fontRef idx="minor">
+            <a:schemeClr val="lt1"/>
+          </a:fontRef>
+        </p:style>
+        <p:txBody>
+          <a:bodyPr rtlCol="0" anchor="ctr"/>
+          <a:lstStyle/>
+          <a:p>
+            <a:pPr algn="ctr"/>
+            <a:endParaRPr lang="ko-KR" altLang="en-US"/>
+          </a:p>
+        </p:txBody>
+      </p:sp>
+      <p:sp>
+        <p:nvSpPr>
+          <p:cNvPr id="8" name="직사각형 7"/>
+          <p:cNvSpPr/>
+          <p:nvPr/>
+        </p:nvSpPr>
+        <p:spPr>
+          <a:xfrm>
+            <a:off x="1704975" y="971550"/>
+            <a:ext cx="1028700" cy="234007"/>
+          </a:xfrm>
+          <a:prstGeom prst="rect">
+            <a:avLst/>
+          </a:prstGeom>
+        </p:spPr>
+        <p:style>
+          <a:lnRef idx="2">
+            <a:schemeClr val="accent1">
+              <a:shade val="50000"/>
+            </a:schemeClr>
+          </a:lnRef>
+          <a:fillRef idx="1">
+            <a:schemeClr val="accent1"/>
+          </a:fillRef>
+          <a:effectRef idx="0">
+            <a:schemeClr val="accent1"/>
+          </a:effectRef>
+          <a:fontRef idx="minor">
+            <a:schemeClr val="lt1"/>
+          </a:fontRef>
+        </p:style>
+        <p:txBody>
+          <a:bodyPr rtlCol="0" anchor="ctr"/>
+          <a:lstStyle/>
+          <a:p>
+            <a:pPr algn="ctr"/>
+            <a:endParaRPr lang="ko-KR" altLang="en-US"/>
+          </a:p>
+        </p:txBody>
+      </p:sp>
+      <p:sp>
+        <p:nvSpPr>
+          <p:cNvPr id="18" name="직사각형 17"/>
+          <p:cNvSpPr/>
+          <p:nvPr/>
+        </p:nvSpPr>
+        <p:spPr>
+          <a:xfrm>
+            <a:off x="571501" y="1310332"/>
+            <a:ext cx="10487024" cy="4790430"/>
+          </a:xfrm>
+          <a:prstGeom prst="rect">
+            <a:avLst/>
+          </a:prstGeom>
+        </p:spPr>
+        <p:style>
+          <a:lnRef idx="2">
+            <a:schemeClr val="accent1">
+              <a:shade val="50000"/>
+            </a:schemeClr>
+          </a:lnRef>
+          <a:fillRef idx="1">
+            <a:schemeClr val="accent1"/>
+          </a:fillRef>
+          <a:effectRef idx="0">
+            <a:schemeClr val="accent1"/>
+          </a:effectRef>
+          <a:fontRef idx="minor">
+            <a:schemeClr val="lt1"/>
+          </a:fontRef>
+        </p:style>
+        <p:txBody>
+          <a:bodyPr rtlCol="0" anchor="ctr"/>
+          <a:lstStyle/>
+          <a:p>
+            <a:pPr algn="ctr"/>
+            <a:endParaRPr lang="ko-KR" altLang="en-US"/>
+          </a:p>
+        </p:txBody>
+      </p:sp>
+      <p:sp>
+        <p:nvSpPr>
+          <p:cNvPr id="11" name="직사각형 10"/>
+          <p:cNvSpPr/>
+          <p:nvPr/>
+        </p:nvSpPr>
+        <p:spPr>
+          <a:xfrm>
+            <a:off x="758741" y="1468892"/>
+            <a:ext cx="5056271" cy="1338477"/>
+          </a:xfrm>
+          <a:prstGeom prst="rect">
+            <a:avLst/>
+          </a:prstGeom>
+          <a:solidFill>
+            <a:schemeClr val="tx2">
+              <a:lumMod val="20000"/>
+              <a:lumOff val="80000"/>
+            </a:schemeClr>
+          </a:solidFill>
+        </p:spPr>
+        <p:style>
+          <a:lnRef idx="2">
+            <a:schemeClr val="accent1">
+              <a:shade val="50000"/>
+            </a:schemeClr>
+          </a:lnRef>
+          <a:fillRef idx="1">
+            <a:schemeClr val="accent1"/>
+          </a:fillRef>
+          <a:effectRef idx="0">
+            <a:schemeClr val="accent1"/>
+          </a:effectRef>
+          <a:fontRef idx="minor">
+            <a:schemeClr val="lt1"/>
+          </a:fontRef>
+        </p:style>
+        <p:txBody>
+          <a:bodyPr rtlCol="0" anchor="ctr"/>
+          <a:lstStyle/>
+          <a:p>
+            <a:pPr algn="ctr"/>
+            <a:endParaRPr lang="ko-KR" altLang="en-US"/>
+          </a:p>
+        </p:txBody>
+      </p:sp>
+      <p:sp>
+        <p:nvSpPr>
+          <p:cNvPr id="13" name="직사각형 12"/>
+          <p:cNvSpPr/>
+          <p:nvPr/>
+        </p:nvSpPr>
+        <p:spPr>
+          <a:xfrm>
+            <a:off x="758740" y="2965929"/>
+            <a:ext cx="5056271" cy="1338477"/>
+          </a:xfrm>
+          <a:prstGeom prst="rect">
+            <a:avLst/>
+          </a:prstGeom>
+          <a:solidFill>
+            <a:schemeClr val="tx2">
+              <a:lumMod val="20000"/>
+              <a:lumOff val="80000"/>
+            </a:schemeClr>
+          </a:solidFill>
+        </p:spPr>
+        <p:style>
+          <a:lnRef idx="2">
+            <a:schemeClr val="accent1">
+              <a:shade val="50000"/>
+            </a:schemeClr>
+          </a:lnRef>
+          <a:fillRef idx="1">
+            <a:schemeClr val="accent1"/>
+          </a:fillRef>
+          <a:effectRef idx="0">
+            <a:schemeClr val="accent1"/>
+          </a:effectRef>
+          <a:fontRef idx="minor">
+            <a:schemeClr val="lt1"/>
+          </a:fontRef>
+        </p:style>
+        <p:txBody>
+          <a:bodyPr rtlCol="0" anchor="ctr"/>
+          <a:lstStyle/>
+          <a:p>
+            <a:pPr algn="ctr"/>
+            <a:endParaRPr lang="ko-KR" altLang="en-US"/>
+          </a:p>
+        </p:txBody>
+      </p:sp>
+    </p:spTree>
+    <p:extLst>
+      <p:ext uri="{BB962C8B-B14F-4D97-AF65-F5344CB8AC3E}">
+        <p14:creationId xmlns:p14="http://schemas.microsoft.com/office/powerpoint/2010/main" val="2571391398"/>
       </p:ext>
     </p:extLst>
   </p:cSld>

</xml_diff>

<commit_message>
20260703 commit : for_weekends <- 호환성
</commit_message>
<xml_diff>
--- a/ppt/UI.pptx
+++ b/ppt/UI.pptx
@@ -5,9 +5,8 @@
     <p:sldMasterId id="2147483648" r:id="rId1"/>
   </p:sldMasterIdLst>
   <p:sldIdLst>
-    <p:sldId id="256" r:id="rId2"/>
-    <p:sldId id="257" r:id="rId3"/>
-    <p:sldId id="258" r:id="rId4"/>
+    <p:sldId id="258" r:id="rId2"/>
+    <p:sldId id="259" r:id="rId3"/>
   </p:sldIdLst>
   <p:sldSz cx="12192000" cy="6858000"/>
   <p:notesSz cx="6858000" cy="9144000"/>
@@ -245,7 +244,7 @@
           <a:p>
             <a:fld id="{7D6D5DB7-34A5-4DF0-94A0-9851E520DD60}" type="datetimeFigureOut">
               <a:rPr lang="ko-KR" altLang="en-US" smtClean="0"/>
-              <a:t>2026-06-26</a:t>
+              <a:t>2026-07-03</a:t>
             </a:fld>
             <a:endParaRPr lang="ko-KR" altLang="en-US"/>
           </a:p>
@@ -415,7 +414,7 @@
           <a:p>
             <a:fld id="{7D6D5DB7-34A5-4DF0-94A0-9851E520DD60}" type="datetimeFigureOut">
               <a:rPr lang="ko-KR" altLang="en-US" smtClean="0"/>
-              <a:t>2026-06-26</a:t>
+              <a:t>2026-07-03</a:t>
             </a:fld>
             <a:endParaRPr lang="ko-KR" altLang="en-US"/>
           </a:p>
@@ -595,7 +594,7 @@
           <a:p>
             <a:fld id="{7D6D5DB7-34A5-4DF0-94A0-9851E520DD60}" type="datetimeFigureOut">
               <a:rPr lang="ko-KR" altLang="en-US" smtClean="0"/>
-              <a:t>2026-06-26</a:t>
+              <a:t>2026-07-03</a:t>
             </a:fld>
             <a:endParaRPr lang="ko-KR" altLang="en-US"/>
           </a:p>
@@ -765,7 +764,7 @@
           <a:p>
             <a:fld id="{7D6D5DB7-34A5-4DF0-94A0-9851E520DD60}" type="datetimeFigureOut">
               <a:rPr lang="ko-KR" altLang="en-US" smtClean="0"/>
-              <a:t>2026-06-26</a:t>
+              <a:t>2026-07-03</a:t>
             </a:fld>
             <a:endParaRPr lang="ko-KR" altLang="en-US"/>
           </a:p>
@@ -1011,7 +1010,7 @@
           <a:p>
             <a:fld id="{7D6D5DB7-34A5-4DF0-94A0-9851E520DD60}" type="datetimeFigureOut">
               <a:rPr lang="ko-KR" altLang="en-US" smtClean="0"/>
-              <a:t>2026-06-26</a:t>
+              <a:t>2026-07-03</a:t>
             </a:fld>
             <a:endParaRPr lang="ko-KR" altLang="en-US"/>
           </a:p>
@@ -1243,7 +1242,7 @@
           <a:p>
             <a:fld id="{7D6D5DB7-34A5-4DF0-94A0-9851E520DD60}" type="datetimeFigureOut">
               <a:rPr lang="ko-KR" altLang="en-US" smtClean="0"/>
-              <a:t>2026-06-26</a:t>
+              <a:t>2026-07-03</a:t>
             </a:fld>
             <a:endParaRPr lang="ko-KR" altLang="en-US"/>
           </a:p>
@@ -1610,7 +1609,7 @@
           <a:p>
             <a:fld id="{7D6D5DB7-34A5-4DF0-94A0-9851E520DD60}" type="datetimeFigureOut">
               <a:rPr lang="ko-KR" altLang="en-US" smtClean="0"/>
-              <a:t>2026-06-26</a:t>
+              <a:t>2026-07-03</a:t>
             </a:fld>
             <a:endParaRPr lang="ko-KR" altLang="en-US"/>
           </a:p>
@@ -1728,7 +1727,7 @@
           <a:p>
             <a:fld id="{7D6D5DB7-34A5-4DF0-94A0-9851E520DD60}" type="datetimeFigureOut">
               <a:rPr lang="ko-KR" altLang="en-US" smtClean="0"/>
-              <a:t>2026-06-26</a:t>
+              <a:t>2026-07-03</a:t>
             </a:fld>
             <a:endParaRPr lang="ko-KR" altLang="en-US"/>
           </a:p>
@@ -1823,7 +1822,7 @@
           <a:p>
             <a:fld id="{7D6D5DB7-34A5-4DF0-94A0-9851E520DD60}" type="datetimeFigureOut">
               <a:rPr lang="ko-KR" altLang="en-US" smtClean="0"/>
-              <a:t>2026-06-26</a:t>
+              <a:t>2026-07-03</a:t>
             </a:fld>
             <a:endParaRPr lang="ko-KR" altLang="en-US"/>
           </a:p>
@@ -2100,7 +2099,7 @@
           <a:p>
             <a:fld id="{7D6D5DB7-34A5-4DF0-94A0-9851E520DD60}" type="datetimeFigureOut">
               <a:rPr lang="ko-KR" altLang="en-US" smtClean="0"/>
-              <a:t>2026-06-26</a:t>
+              <a:t>2026-07-03</a:t>
             </a:fld>
             <a:endParaRPr lang="ko-KR" altLang="en-US"/>
           </a:p>
@@ -2353,7 +2352,7 @@
           <a:p>
             <a:fld id="{7D6D5DB7-34A5-4DF0-94A0-9851E520DD60}" type="datetimeFigureOut">
               <a:rPr lang="ko-KR" altLang="en-US" smtClean="0"/>
-              <a:t>2026-06-26</a:t>
+              <a:t>2026-07-03</a:t>
             </a:fld>
             <a:endParaRPr lang="ko-KR" altLang="en-US"/>
           </a:p>
@@ -2566,7 +2565,7 @@
           <a:p>
             <a:fld id="{7D6D5DB7-34A5-4DF0-94A0-9851E520DD60}" type="datetimeFigureOut">
               <a:rPr lang="ko-KR" altLang="en-US" smtClean="0"/>
-              <a:t>2026-06-26</a:t>
+              <a:t>2026-07-03</a:t>
             </a:fld>
             <a:endParaRPr lang="ko-KR" altLang="en-US"/>
           </a:p>
@@ -2979,8 +2978,8 @@
         </p:nvGrpSpPr>
         <p:grpSpPr>
           <a:xfrm>
-            <a:off x="409575" y="866775"/>
-            <a:ext cx="10810875" cy="5391150"/>
+            <a:off x="0" y="0"/>
+            <a:ext cx="12192000" cy="6858000"/>
             <a:chOff x="409575" y="866775"/>
             <a:chExt cx="10810875" cy="5391150"/>
           </a:xfrm>
@@ -3000,88 +2999,11 @@
               <a:avLst/>
             </a:prstGeom>
             <a:solidFill>
-              <a:schemeClr val="bg2"/>
+              <a:schemeClr val="accent1">
+                <a:lumMod val="20000"/>
+                <a:lumOff val="80000"/>
+              </a:schemeClr>
             </a:solidFill>
-          </p:spPr>
-          <p:style>
-            <a:lnRef idx="2">
-              <a:schemeClr val="accent1">
-                <a:shade val="50000"/>
-              </a:schemeClr>
-            </a:lnRef>
-            <a:fillRef idx="1">
-              <a:schemeClr val="accent1"/>
-            </a:fillRef>
-            <a:effectRef idx="0">
-              <a:schemeClr val="accent1"/>
-            </a:effectRef>
-            <a:fontRef idx="minor">
-              <a:schemeClr val="lt1"/>
-            </a:fontRef>
-          </p:style>
-          <p:txBody>
-            <a:bodyPr rtlCol="0" anchor="ctr"/>
-            <a:lstStyle/>
-            <a:p>
-              <a:pPr algn="ctr"/>
-              <a:endParaRPr lang="ko-KR" altLang="en-US"/>
-            </a:p>
-          </p:txBody>
-        </p:sp>
-        <p:sp>
-          <p:nvSpPr>
-            <p:cNvPr id="4" name="직사각형 3"/>
-            <p:cNvSpPr/>
-            <p:nvPr/>
-          </p:nvSpPr>
-          <p:spPr>
-            <a:xfrm>
-              <a:off x="571500" y="1290637"/>
-              <a:ext cx="7620000" cy="4810125"/>
-            </a:xfrm>
-            <a:prstGeom prst="rect">
-              <a:avLst/>
-            </a:prstGeom>
-          </p:spPr>
-          <p:style>
-            <a:lnRef idx="2">
-              <a:schemeClr val="accent1">
-                <a:shade val="50000"/>
-              </a:schemeClr>
-            </a:lnRef>
-            <a:fillRef idx="1">
-              <a:schemeClr val="accent1"/>
-            </a:fillRef>
-            <a:effectRef idx="0">
-              <a:schemeClr val="accent1"/>
-            </a:effectRef>
-            <a:fontRef idx="minor">
-              <a:schemeClr val="lt1"/>
-            </a:fontRef>
-          </p:style>
-          <p:txBody>
-            <a:bodyPr rtlCol="0" anchor="ctr"/>
-            <a:lstStyle/>
-            <a:p>
-              <a:pPr algn="ctr"/>
-              <a:endParaRPr lang="ko-KR" altLang="en-US"/>
-            </a:p>
-          </p:txBody>
-        </p:sp>
-        <p:sp>
-          <p:nvSpPr>
-            <p:cNvPr id="5" name="직사각형 4"/>
-            <p:cNvSpPr/>
-            <p:nvPr/>
-          </p:nvSpPr>
-          <p:spPr>
-            <a:xfrm>
-              <a:off x="8372475" y="1290638"/>
-              <a:ext cx="2695575" cy="2543425"/>
-            </a:xfrm>
-            <a:prstGeom prst="rect">
-              <a:avLst/>
-            </a:prstGeom>
           </p:spPr>
           <p:style>
             <a:lnRef idx="2">
@@ -3116,12 +3038,18 @@
           </p:nvSpPr>
           <p:spPr>
             <a:xfrm>
-              <a:off x="571500" y="971550"/>
-              <a:ext cx="1028700" cy="234007"/>
+              <a:off x="596551" y="1009127"/>
+              <a:ext cx="1975199" cy="5091633"/>
             </a:xfrm>
             <a:prstGeom prst="rect">
               <a:avLst/>
             </a:prstGeom>
+            <a:solidFill>
+              <a:schemeClr val="accent5">
+                <a:lumMod val="60000"/>
+                <a:lumOff val="40000"/>
+              </a:schemeClr>
+            </a:solidFill>
           </p:spPr>
           <p:style>
             <a:lnRef idx="2">
@@ -3150,18 +3078,24 @@
         </p:sp>
         <p:sp>
           <p:nvSpPr>
-            <p:cNvPr id="8" name="직사각형 7"/>
+            <p:cNvPr id="18" name="직사각형 17"/>
             <p:cNvSpPr/>
             <p:nvPr/>
           </p:nvSpPr>
           <p:spPr>
             <a:xfrm>
-              <a:off x="1704975" y="971550"/>
-              <a:ext cx="1028700" cy="234007"/>
+              <a:off x="2733675" y="1009127"/>
+              <a:ext cx="8324850" cy="4136338"/>
             </a:xfrm>
             <a:prstGeom prst="rect">
               <a:avLst/>
             </a:prstGeom>
+            <a:solidFill>
+              <a:schemeClr val="accent5">
+                <a:lumMod val="60000"/>
+                <a:lumOff val="40000"/>
+              </a:schemeClr>
+            </a:solidFill>
           </p:spPr>
           <p:style>
             <a:lnRef idx="2">
@@ -3196,12 +3130,109 @@
           </p:nvSpPr>
           <p:spPr>
             <a:xfrm>
-              <a:off x="10777537" y="971550"/>
-              <a:ext cx="280988" cy="235743"/>
+              <a:off x="2919243" y="2165739"/>
+              <a:ext cx="7979456" cy="836391"/>
             </a:xfrm>
             <a:prstGeom prst="rect">
               <a:avLst/>
             </a:prstGeom>
+            <a:solidFill>
+              <a:schemeClr val="accent1">
+                <a:lumMod val="20000"/>
+                <a:lumOff val="80000"/>
+              </a:schemeClr>
+            </a:solidFill>
+          </p:spPr>
+          <p:style>
+            <a:lnRef idx="2">
+              <a:schemeClr val="accent1">
+                <a:shade val="50000"/>
+              </a:schemeClr>
+            </a:lnRef>
+            <a:fillRef idx="1">
+              <a:schemeClr val="accent1"/>
+            </a:fillRef>
+            <a:effectRef idx="0">
+              <a:schemeClr val="accent1"/>
+            </a:effectRef>
+            <a:fontRef idx="minor">
+              <a:schemeClr val="lt1"/>
+            </a:fontRef>
+          </p:style>
+          <p:txBody>
+            <a:bodyPr rtlCol="0" anchor="ctr"/>
+            <a:lstStyle/>
+            <a:p>
+              <a:pPr algn="ctr"/>
+              <a:endParaRPr lang="ko-KR" altLang="en-US"/>
+            </a:p>
+          </p:txBody>
+        </p:sp>
+      </p:grpSp>
+    </p:spTree>
+    <p:extLst>
+      <p:ext uri="{BB962C8B-B14F-4D97-AF65-F5344CB8AC3E}">
+        <p14:creationId xmlns:p14="http://schemas.microsoft.com/office/powerpoint/2010/main" val="2571391398"/>
+      </p:ext>
+    </p:extLst>
+  </p:cSld>
+  <p:clrMapOvr>
+    <a:masterClrMapping/>
+  </p:clrMapOvr>
+</p:sld>
+</file>
+
+<file path=ppt/slides/slide2.xml><?xml version="1.0" encoding="utf-8"?>
+<p:sld xmlns:a="http://schemas.openxmlformats.org/drawingml/2006/main" xmlns:r="http://schemas.openxmlformats.org/officeDocument/2006/relationships" xmlns:p="http://schemas.openxmlformats.org/presentationml/2006/main">
+  <p:cSld>
+    <p:spTree>
+      <p:nvGrpSpPr>
+        <p:cNvPr id="1" name=""/>
+        <p:cNvGrpSpPr/>
+        <p:nvPr/>
+      </p:nvGrpSpPr>
+      <p:grpSpPr>
+        <a:xfrm>
+          <a:off x="0" y="0"/>
+          <a:ext cx="0" cy="0"/>
+          <a:chOff x="0" y="0"/>
+          <a:chExt cx="0" cy="0"/>
+        </a:xfrm>
+      </p:grpSpPr>
+      <p:grpSp>
+        <p:nvGrpSpPr>
+          <p:cNvPr id="2" name="그룹 1"/>
+          <p:cNvGrpSpPr/>
+          <p:nvPr/>
+        </p:nvGrpSpPr>
+        <p:grpSpPr>
+          <a:xfrm>
+            <a:off x="0" y="0"/>
+            <a:ext cx="12192000" cy="6858000"/>
+            <a:chOff x="409575" y="866775"/>
+            <a:chExt cx="10810875" cy="5391150"/>
+          </a:xfrm>
+        </p:grpSpPr>
+        <p:sp>
+          <p:nvSpPr>
+            <p:cNvPr id="12" name="직사각형 11"/>
+            <p:cNvSpPr/>
+            <p:nvPr/>
+          </p:nvSpPr>
+          <p:spPr>
+            <a:xfrm>
+              <a:off x="409575" y="866775"/>
+              <a:ext cx="10810875" cy="5391150"/>
+            </a:xfrm>
+            <a:prstGeom prst="rect">
+              <a:avLst/>
+            </a:prstGeom>
+            <a:solidFill>
+              <a:schemeClr val="accent1">
+                <a:lumMod val="20000"/>
+                <a:lumOff val="80000"/>
+              </a:schemeClr>
+            </a:solidFill>
           </p:spPr>
           <p:style>
             <a:lnRef idx="2">
@@ -3230,18 +3261,24 @@
         </p:sp>
         <p:sp>
           <p:nvSpPr>
-            <p:cNvPr id="13" name="직사각형 12"/>
+            <p:cNvPr id="7" name="직사각형 6"/>
             <p:cNvSpPr/>
             <p:nvPr/>
           </p:nvSpPr>
           <p:spPr>
             <a:xfrm>
-              <a:off x="10377487" y="971550"/>
-              <a:ext cx="280988" cy="235743"/>
+              <a:off x="596551" y="1009127"/>
+              <a:ext cx="1975199" cy="5091633"/>
             </a:xfrm>
             <a:prstGeom prst="rect">
               <a:avLst/>
             </a:prstGeom>
+            <a:solidFill>
+              <a:schemeClr val="accent5">
+                <a:lumMod val="60000"/>
+                <a:lumOff val="40000"/>
+              </a:schemeClr>
+            </a:solidFill>
           </p:spPr>
           <p:style>
             <a:lnRef idx="2">
@@ -3270,18 +3307,70 @@
         </p:sp>
         <p:sp>
           <p:nvSpPr>
-            <p:cNvPr id="14" name="직사각형 13"/>
+            <p:cNvPr id="18" name="직사각형 17"/>
             <p:cNvSpPr/>
             <p:nvPr/>
           </p:nvSpPr>
           <p:spPr>
             <a:xfrm>
-              <a:off x="2838450" y="971550"/>
-              <a:ext cx="1028700" cy="234007"/>
+              <a:off x="2733675" y="1009127"/>
+              <a:ext cx="8324850" cy="5248797"/>
             </a:xfrm>
             <a:prstGeom prst="rect">
               <a:avLst/>
             </a:prstGeom>
+            <a:solidFill>
+              <a:schemeClr val="accent5">
+                <a:lumMod val="60000"/>
+                <a:lumOff val="40000"/>
+              </a:schemeClr>
+            </a:solidFill>
+          </p:spPr>
+          <p:style>
+            <a:lnRef idx="2">
+              <a:schemeClr val="accent1">
+                <a:shade val="50000"/>
+              </a:schemeClr>
+            </a:lnRef>
+            <a:fillRef idx="1">
+              <a:schemeClr val="accent1"/>
+            </a:fillRef>
+            <a:effectRef idx="0">
+              <a:schemeClr val="accent1"/>
+            </a:effectRef>
+            <a:fontRef idx="minor">
+              <a:schemeClr val="lt1"/>
+            </a:fontRef>
+          </p:style>
+          <p:txBody>
+            <a:bodyPr rtlCol="0" anchor="ctr"/>
+            <a:lstStyle/>
+            <a:p>
+              <a:pPr algn="ctr"/>
+              <a:endParaRPr lang="ko-KR" altLang="en-US"/>
+            </a:p>
+          </p:txBody>
+        </p:sp>
+        <p:sp>
+          <p:nvSpPr>
+            <p:cNvPr id="11" name="직사각형 10"/>
+            <p:cNvSpPr/>
+            <p:nvPr/>
+          </p:nvSpPr>
+          <p:spPr>
+            <a:xfrm>
+              <a:off x="2850589" y="1749199"/>
+              <a:ext cx="3960000" cy="4207101"/>
+            </a:xfrm>
+            <a:prstGeom prst="rect">
+              <a:avLst/>
+            </a:prstGeom>
+            <a:solidFill>
+              <a:schemeClr val="accent1">
+                <a:lumMod val="20000"/>
+                <a:lumOff val="80000"/>
+              </a:schemeClr>
+            </a:solidFill>
           </p:spPr>
           <p:style>
             <a:lnRef idx="2">
@@ -3316,104 +3405,14 @@
           </p:nvSpPr>
           <p:spPr>
             <a:xfrm>
-              <a:off x="3971925" y="971550"/>
-              <a:ext cx="1028700" cy="234007"/>
-            </a:xfrm>
-            <a:prstGeom prst="rect">
-              <a:avLst/>
-            </a:prstGeom>
-          </p:spPr>
-          <p:style>
-            <a:lnRef idx="2">
-              <a:schemeClr val="accent1">
-                <a:shade val="50000"/>
-              </a:schemeClr>
-            </a:lnRef>
-            <a:fillRef idx="1">
-              <a:schemeClr val="accent1"/>
-            </a:fillRef>
-            <a:effectRef idx="0">
-              <a:schemeClr val="accent1"/>
-            </a:effectRef>
-            <a:fontRef idx="minor">
-              <a:schemeClr val="lt1"/>
-            </a:fontRef>
-          </p:style>
-          <p:txBody>
-            <a:bodyPr rtlCol="0" anchor="ctr"/>
-            <a:lstStyle/>
-            <a:p>
-              <a:pPr algn="ctr"/>
-              <a:endParaRPr lang="ko-KR" altLang="en-US"/>
-            </a:p>
-          </p:txBody>
-        </p:sp>
-        <p:sp>
-          <p:nvSpPr>
-            <p:cNvPr id="17" name="직사각형 16"/>
-            <p:cNvSpPr/>
-            <p:nvPr/>
-          </p:nvSpPr>
-          <p:spPr>
-            <a:xfrm>
-              <a:off x="8515350" y="1450181"/>
-              <a:ext cx="2438400" cy="867133"/>
+              <a:off x="6954557" y="1749199"/>
+              <a:ext cx="3960000" cy="4207101"/>
             </a:xfrm>
             <a:prstGeom prst="rect">
               <a:avLst/>
             </a:prstGeom>
             <a:solidFill>
-              <a:schemeClr val="accent2">
-                <a:lumMod val="60000"/>
-                <a:lumOff val="40000"/>
-              </a:schemeClr>
-            </a:solidFill>
-          </p:spPr>
-          <p:style>
-            <a:lnRef idx="2">
               <a:schemeClr val="accent1">
-                <a:shade val="50000"/>
-              </a:schemeClr>
-            </a:lnRef>
-            <a:fillRef idx="1">
-              <a:schemeClr val="accent1"/>
-            </a:fillRef>
-            <a:effectRef idx="0">
-              <a:schemeClr val="accent1"/>
-            </a:effectRef>
-            <a:fontRef idx="minor">
-              <a:schemeClr val="lt1"/>
-            </a:fontRef>
-          </p:style>
-          <p:txBody>
-            <a:bodyPr rtlCol="0" anchor="ctr"/>
-            <a:lstStyle/>
-            <a:p>
-              <a:pPr algn="ctr"/>
-              <a:r>
-                <a:rPr lang="en-US" altLang="ko-KR" dirty="0" smtClean="0"/>
-                <a:t>NEW</a:t>
-              </a:r>
-              <a:endParaRPr lang="ko-KR" altLang="en-US" dirty="0"/>
-            </a:p>
-          </p:txBody>
-        </p:sp>
-        <p:sp>
-          <p:nvSpPr>
-            <p:cNvPr id="18" name="직사각형 17"/>
-            <p:cNvSpPr/>
-            <p:nvPr/>
-          </p:nvSpPr>
-          <p:spPr>
-            <a:xfrm>
-              <a:off x="8515350" y="2476857"/>
-              <a:ext cx="2438400" cy="867133"/>
-            </a:xfrm>
-            <a:prstGeom prst="rect">
-              <a:avLst/>
-            </a:prstGeom>
-            <a:solidFill>
-              <a:schemeClr val="tx2">
                 <a:lumMod val="20000"/>
                 <a:lumOff val="80000"/>
               </a:schemeClr>
@@ -3447,60 +3446,20 @@
       </p:grpSp>
       <p:sp>
         <p:nvSpPr>
-          <p:cNvPr id="20" name="직사각형 19"/>
+          <p:cNvPr id="10" name="직사각형 9"/>
           <p:cNvSpPr/>
           <p:nvPr/>
         </p:nvSpPr>
         <p:spPr>
           <a:xfrm>
-            <a:off x="8386762" y="3993606"/>
-            <a:ext cx="2695575" cy="2099475"/>
-          </a:xfrm>
-          <a:prstGeom prst="rect">
-            <a:avLst/>
-          </a:prstGeom>
-        </p:spPr>
-        <p:style>
-          <a:lnRef idx="2">
-            <a:schemeClr val="accent1">
-              <a:shade val="50000"/>
-            </a:schemeClr>
-          </a:lnRef>
-          <a:fillRef idx="1">
-            <a:schemeClr val="accent1"/>
-          </a:fillRef>
-          <a:effectRef idx="0">
-            <a:schemeClr val="accent1"/>
-          </a:effectRef>
-          <a:fontRef idx="minor">
-            <a:schemeClr val="lt1"/>
-          </a:fontRef>
-        </p:style>
-        <p:txBody>
-          <a:bodyPr rtlCol="0" anchor="ctr"/>
-          <a:lstStyle/>
-          <a:p>
-            <a:pPr algn="ctr"/>
-            <a:endParaRPr lang="ko-KR" altLang="en-US"/>
-          </a:p>
-        </p:txBody>
-      </p:sp>
-      <p:sp>
-        <p:nvSpPr>
-          <p:cNvPr id="21" name="직사각형 20"/>
-          <p:cNvSpPr/>
-          <p:nvPr/>
-        </p:nvSpPr>
-        <p:spPr>
-          <a:xfrm>
-            <a:off x="8515350" y="4176211"/>
-            <a:ext cx="2438400" cy="395790"/>
+            <a:off x="2752862" y="370115"/>
+            <a:ext cx="4465903" cy="631371"/>
           </a:xfrm>
           <a:prstGeom prst="rect">
             <a:avLst/>
           </a:prstGeom>
           <a:solidFill>
-            <a:schemeClr val="tx2">
+            <a:schemeClr val="accent1">
               <a:lumMod val="20000"/>
               <a:lumOff val="80000"/>
             </a:schemeClr>
@@ -3533,20 +3492,20 @@
       </p:sp>
       <p:sp>
         <p:nvSpPr>
-          <p:cNvPr id="22" name="직사각형 21"/>
+          <p:cNvPr id="13" name="직사각형 12"/>
           <p:cNvSpPr/>
           <p:nvPr/>
         </p:nvSpPr>
         <p:spPr>
           <a:xfrm>
-            <a:off x="8515350" y="4679638"/>
-            <a:ext cx="2438400" cy="395790"/>
+            <a:off x="7381125" y="370115"/>
+            <a:ext cx="4465903" cy="631371"/>
           </a:xfrm>
           <a:prstGeom prst="rect">
             <a:avLst/>
           </a:prstGeom>
           <a:solidFill>
-            <a:schemeClr val="tx2">
+            <a:schemeClr val="accent1">
               <a:lumMod val="20000"/>
               <a:lumOff val="80000"/>
             </a:schemeClr>
@@ -3577,764 +3536,10 @@
           </a:p>
         </p:txBody>
       </p:sp>
-      <p:sp>
-        <p:nvSpPr>
-          <p:cNvPr id="23" name="직사각형 22"/>
-          <p:cNvSpPr/>
-          <p:nvPr/>
-        </p:nvSpPr>
-        <p:spPr>
-          <a:xfrm>
-            <a:off x="8515350" y="5183065"/>
-            <a:ext cx="2438400" cy="395790"/>
-          </a:xfrm>
-          <a:prstGeom prst="rect">
-            <a:avLst/>
-          </a:prstGeom>
-          <a:solidFill>
-            <a:schemeClr val="tx2">
-              <a:lumMod val="20000"/>
-              <a:lumOff val="80000"/>
-            </a:schemeClr>
-          </a:solidFill>
-        </p:spPr>
-        <p:style>
-          <a:lnRef idx="2">
-            <a:schemeClr val="accent1">
-              <a:shade val="50000"/>
-            </a:schemeClr>
-          </a:lnRef>
-          <a:fillRef idx="1">
-            <a:schemeClr val="accent1"/>
-          </a:fillRef>
-          <a:effectRef idx="0">
-            <a:schemeClr val="accent1"/>
-          </a:effectRef>
-          <a:fontRef idx="minor">
-            <a:schemeClr val="lt1"/>
-          </a:fontRef>
-        </p:style>
-        <p:txBody>
-          <a:bodyPr rtlCol="0" anchor="ctr"/>
-          <a:lstStyle/>
-          <a:p>
-            <a:pPr algn="ctr"/>
-            <a:endParaRPr lang="ko-KR" altLang="en-US"/>
-          </a:p>
-        </p:txBody>
-      </p:sp>
-      <p:sp>
-        <p:nvSpPr>
-          <p:cNvPr id="24" name="직사각형 23"/>
-          <p:cNvSpPr/>
-          <p:nvPr/>
-        </p:nvSpPr>
-        <p:spPr>
-          <a:xfrm>
-            <a:off x="8515350" y="5697291"/>
-            <a:ext cx="2438400" cy="238288"/>
-          </a:xfrm>
-          <a:prstGeom prst="rect">
-            <a:avLst/>
-          </a:prstGeom>
-          <a:solidFill>
-            <a:schemeClr val="tx2">
-              <a:lumMod val="20000"/>
-              <a:lumOff val="80000"/>
-            </a:schemeClr>
-          </a:solidFill>
-        </p:spPr>
-        <p:style>
-          <a:lnRef idx="2">
-            <a:schemeClr val="accent1">
-              <a:shade val="50000"/>
-            </a:schemeClr>
-          </a:lnRef>
-          <a:fillRef idx="1">
-            <a:schemeClr val="accent1"/>
-          </a:fillRef>
-          <a:effectRef idx="0">
-            <a:schemeClr val="accent1"/>
-          </a:effectRef>
-          <a:fontRef idx="minor">
-            <a:schemeClr val="lt1"/>
-          </a:fontRef>
-        </p:style>
-        <p:txBody>
-          <a:bodyPr rtlCol="0" anchor="ctr"/>
-          <a:lstStyle/>
-          <a:p>
-            <a:pPr algn="ctr"/>
-            <a:endParaRPr lang="ko-KR" altLang="en-US"/>
-          </a:p>
-        </p:txBody>
-      </p:sp>
     </p:spTree>
     <p:extLst>
       <p:ext uri="{BB962C8B-B14F-4D97-AF65-F5344CB8AC3E}">
-        <p14:creationId xmlns:p14="http://schemas.microsoft.com/office/powerpoint/2010/main" val="1089253782"/>
-      </p:ext>
-    </p:extLst>
-  </p:cSld>
-  <p:clrMapOvr>
-    <a:masterClrMapping/>
-  </p:clrMapOvr>
-</p:sld>
-</file>
-
-<file path=ppt/slides/slide2.xml><?xml version="1.0" encoding="utf-8"?>
-<p:sld xmlns:a="http://schemas.openxmlformats.org/drawingml/2006/main" xmlns:r="http://schemas.openxmlformats.org/officeDocument/2006/relationships" xmlns:p="http://schemas.openxmlformats.org/presentationml/2006/main">
-  <p:cSld>
-    <p:spTree>
-      <p:nvGrpSpPr>
-        <p:cNvPr id="1" name=""/>
-        <p:cNvGrpSpPr/>
-        <p:nvPr/>
-      </p:nvGrpSpPr>
-      <p:grpSpPr>
-        <a:xfrm>
-          <a:off x="0" y="0"/>
-          <a:ext cx="0" cy="0"/>
-          <a:chOff x="0" y="0"/>
-          <a:chExt cx="0" cy="0"/>
-        </a:xfrm>
-      </p:grpSpPr>
-      <p:sp>
-        <p:nvSpPr>
-          <p:cNvPr id="12" name="직사각형 11"/>
-          <p:cNvSpPr/>
-          <p:nvPr/>
-        </p:nvSpPr>
-        <p:spPr>
-          <a:xfrm>
-            <a:off x="409575" y="866775"/>
-            <a:ext cx="10810875" cy="5391150"/>
-          </a:xfrm>
-          <a:prstGeom prst="rect">
-            <a:avLst/>
-          </a:prstGeom>
-          <a:solidFill>
-            <a:schemeClr val="bg2"/>
-          </a:solidFill>
-        </p:spPr>
-        <p:style>
-          <a:lnRef idx="2">
-            <a:schemeClr val="accent1">
-              <a:shade val="50000"/>
-            </a:schemeClr>
-          </a:lnRef>
-          <a:fillRef idx="1">
-            <a:schemeClr val="accent1"/>
-          </a:fillRef>
-          <a:effectRef idx="0">
-            <a:schemeClr val="accent1"/>
-          </a:effectRef>
-          <a:fontRef idx="minor">
-            <a:schemeClr val="lt1"/>
-          </a:fontRef>
-        </p:style>
-        <p:txBody>
-          <a:bodyPr rtlCol="0" anchor="ctr"/>
-          <a:lstStyle/>
-          <a:p>
-            <a:pPr algn="ctr"/>
-            <a:endParaRPr lang="ko-KR" altLang="en-US"/>
-          </a:p>
-        </p:txBody>
-      </p:sp>
-      <p:sp>
-        <p:nvSpPr>
-          <p:cNvPr id="7" name="직사각형 6"/>
-          <p:cNvSpPr/>
-          <p:nvPr/>
-        </p:nvSpPr>
-        <p:spPr>
-          <a:xfrm>
-            <a:off x="571500" y="971550"/>
-            <a:ext cx="1028700" cy="234007"/>
-          </a:xfrm>
-          <a:prstGeom prst="rect">
-            <a:avLst/>
-          </a:prstGeom>
-        </p:spPr>
-        <p:style>
-          <a:lnRef idx="2">
-            <a:schemeClr val="accent1">
-              <a:shade val="50000"/>
-            </a:schemeClr>
-          </a:lnRef>
-          <a:fillRef idx="1">
-            <a:schemeClr val="accent1"/>
-          </a:fillRef>
-          <a:effectRef idx="0">
-            <a:schemeClr val="accent1"/>
-          </a:effectRef>
-          <a:fontRef idx="minor">
-            <a:schemeClr val="lt1"/>
-          </a:fontRef>
-        </p:style>
-        <p:txBody>
-          <a:bodyPr rtlCol="0" anchor="ctr"/>
-          <a:lstStyle/>
-          <a:p>
-            <a:pPr algn="ctr"/>
-            <a:endParaRPr lang="ko-KR" altLang="en-US"/>
-          </a:p>
-        </p:txBody>
-      </p:sp>
-      <p:sp>
-        <p:nvSpPr>
-          <p:cNvPr id="8" name="직사각형 7"/>
-          <p:cNvSpPr/>
-          <p:nvPr/>
-        </p:nvSpPr>
-        <p:spPr>
-          <a:xfrm>
-            <a:off x="1704975" y="971550"/>
-            <a:ext cx="1028700" cy="234007"/>
-          </a:xfrm>
-          <a:prstGeom prst="rect">
-            <a:avLst/>
-          </a:prstGeom>
-        </p:spPr>
-        <p:style>
-          <a:lnRef idx="2">
-            <a:schemeClr val="accent1">
-              <a:shade val="50000"/>
-            </a:schemeClr>
-          </a:lnRef>
-          <a:fillRef idx="1">
-            <a:schemeClr val="accent1"/>
-          </a:fillRef>
-          <a:effectRef idx="0">
-            <a:schemeClr val="accent1"/>
-          </a:effectRef>
-          <a:fontRef idx="minor">
-            <a:schemeClr val="lt1"/>
-          </a:fontRef>
-        </p:style>
-        <p:txBody>
-          <a:bodyPr rtlCol="0" anchor="ctr"/>
-          <a:lstStyle/>
-          <a:p>
-            <a:pPr algn="ctr"/>
-            <a:endParaRPr lang="ko-KR" altLang="en-US"/>
-          </a:p>
-        </p:txBody>
-      </p:sp>
-      <p:sp>
-        <p:nvSpPr>
-          <p:cNvPr id="18" name="직사각형 17"/>
-          <p:cNvSpPr/>
-          <p:nvPr/>
-        </p:nvSpPr>
-        <p:spPr>
-          <a:xfrm>
-            <a:off x="571501" y="1310332"/>
-            <a:ext cx="10487024" cy="4790430"/>
-          </a:xfrm>
-          <a:prstGeom prst="rect">
-            <a:avLst/>
-          </a:prstGeom>
-        </p:spPr>
-        <p:style>
-          <a:lnRef idx="2">
-            <a:schemeClr val="accent1">
-              <a:shade val="50000"/>
-            </a:schemeClr>
-          </a:lnRef>
-          <a:fillRef idx="1">
-            <a:schemeClr val="accent1"/>
-          </a:fillRef>
-          <a:effectRef idx="0">
-            <a:schemeClr val="accent1"/>
-          </a:effectRef>
-          <a:fontRef idx="minor">
-            <a:schemeClr val="lt1"/>
-          </a:fontRef>
-        </p:style>
-        <p:txBody>
-          <a:bodyPr rtlCol="0" anchor="ctr"/>
-          <a:lstStyle/>
-          <a:p>
-            <a:pPr algn="ctr"/>
-            <a:endParaRPr lang="ko-KR" altLang="en-US"/>
-          </a:p>
-        </p:txBody>
-      </p:sp>
-      <p:sp>
-        <p:nvSpPr>
-          <p:cNvPr id="6" name="직사각형 5"/>
-          <p:cNvSpPr/>
-          <p:nvPr/>
-        </p:nvSpPr>
-        <p:spPr>
-          <a:xfrm>
-            <a:off x="718887" y="1451219"/>
-            <a:ext cx="10125576" cy="395790"/>
-          </a:xfrm>
-          <a:prstGeom prst="rect">
-            <a:avLst/>
-          </a:prstGeom>
-          <a:solidFill>
-            <a:schemeClr val="tx2">
-              <a:lumMod val="20000"/>
-              <a:lumOff val="80000"/>
-            </a:schemeClr>
-          </a:solidFill>
-        </p:spPr>
-        <p:style>
-          <a:lnRef idx="2">
-            <a:schemeClr val="accent1">
-              <a:shade val="50000"/>
-            </a:schemeClr>
-          </a:lnRef>
-          <a:fillRef idx="1">
-            <a:schemeClr val="accent1"/>
-          </a:fillRef>
-          <a:effectRef idx="0">
-            <a:schemeClr val="accent1"/>
-          </a:effectRef>
-          <a:fontRef idx="minor">
-            <a:schemeClr val="lt1"/>
-          </a:fontRef>
-        </p:style>
-        <p:txBody>
-          <a:bodyPr rtlCol="0" anchor="ctr"/>
-          <a:lstStyle/>
-          <a:p>
-            <a:pPr algn="ctr"/>
-            <a:endParaRPr lang="ko-KR" altLang="en-US"/>
-          </a:p>
-        </p:txBody>
-      </p:sp>
-      <p:sp>
-        <p:nvSpPr>
-          <p:cNvPr id="9" name="직사각형 8"/>
-          <p:cNvSpPr/>
-          <p:nvPr/>
-        </p:nvSpPr>
-        <p:spPr>
-          <a:xfrm>
-            <a:off x="718887" y="1987896"/>
-            <a:ext cx="10125576" cy="395790"/>
-          </a:xfrm>
-          <a:prstGeom prst="rect">
-            <a:avLst/>
-          </a:prstGeom>
-          <a:solidFill>
-            <a:schemeClr val="tx2">
-              <a:lumMod val="20000"/>
-              <a:lumOff val="80000"/>
-            </a:schemeClr>
-          </a:solidFill>
-        </p:spPr>
-        <p:style>
-          <a:lnRef idx="2">
-            <a:schemeClr val="accent1">
-              <a:shade val="50000"/>
-            </a:schemeClr>
-          </a:lnRef>
-          <a:fillRef idx="1">
-            <a:schemeClr val="accent1"/>
-          </a:fillRef>
-          <a:effectRef idx="0">
-            <a:schemeClr val="accent1"/>
-          </a:effectRef>
-          <a:fontRef idx="minor">
-            <a:schemeClr val="lt1"/>
-          </a:fontRef>
-        </p:style>
-        <p:txBody>
-          <a:bodyPr rtlCol="0" anchor="ctr"/>
-          <a:lstStyle/>
-          <a:p>
-            <a:pPr algn="ctr"/>
-            <a:endParaRPr lang="ko-KR" altLang="en-US"/>
-          </a:p>
-        </p:txBody>
-      </p:sp>
-      <p:sp>
-        <p:nvSpPr>
-          <p:cNvPr id="10" name="직사각형 9"/>
-          <p:cNvSpPr/>
-          <p:nvPr/>
-        </p:nvSpPr>
-        <p:spPr>
-          <a:xfrm>
-            <a:off x="718887" y="2522478"/>
-            <a:ext cx="10125576" cy="395790"/>
-          </a:xfrm>
-          <a:prstGeom prst="rect">
-            <a:avLst/>
-          </a:prstGeom>
-          <a:solidFill>
-            <a:schemeClr val="tx2">
-              <a:lumMod val="20000"/>
-              <a:lumOff val="80000"/>
-            </a:schemeClr>
-          </a:solidFill>
-        </p:spPr>
-        <p:style>
-          <a:lnRef idx="2">
-            <a:schemeClr val="accent1">
-              <a:shade val="50000"/>
-            </a:schemeClr>
-          </a:lnRef>
-          <a:fillRef idx="1">
-            <a:schemeClr val="accent1"/>
-          </a:fillRef>
-          <a:effectRef idx="0">
-            <a:schemeClr val="accent1"/>
-          </a:effectRef>
-          <a:fontRef idx="minor">
-            <a:schemeClr val="lt1"/>
-          </a:fontRef>
-        </p:style>
-        <p:txBody>
-          <a:bodyPr rtlCol="0" anchor="ctr"/>
-          <a:lstStyle/>
-          <a:p>
-            <a:pPr algn="ctr"/>
-            <a:endParaRPr lang="ko-KR" altLang="en-US"/>
-          </a:p>
-        </p:txBody>
-      </p:sp>
-      <p:sp>
-        <p:nvSpPr>
-          <p:cNvPr id="11" name="직사각형 10"/>
-          <p:cNvSpPr/>
-          <p:nvPr/>
-        </p:nvSpPr>
-        <p:spPr>
-          <a:xfrm>
-            <a:off x="718887" y="3057060"/>
-            <a:ext cx="10125576" cy="1338477"/>
-          </a:xfrm>
-          <a:prstGeom prst="rect">
-            <a:avLst/>
-          </a:prstGeom>
-          <a:solidFill>
-            <a:schemeClr val="tx2">
-              <a:lumMod val="20000"/>
-              <a:lumOff val="80000"/>
-            </a:schemeClr>
-          </a:solidFill>
-        </p:spPr>
-        <p:style>
-          <a:lnRef idx="2">
-            <a:schemeClr val="accent1">
-              <a:shade val="50000"/>
-            </a:schemeClr>
-          </a:lnRef>
-          <a:fillRef idx="1">
-            <a:schemeClr val="accent1"/>
-          </a:fillRef>
-          <a:effectRef idx="0">
-            <a:schemeClr val="accent1"/>
-          </a:effectRef>
-          <a:fontRef idx="minor">
-            <a:schemeClr val="lt1"/>
-          </a:fontRef>
-        </p:style>
-        <p:txBody>
-          <a:bodyPr rtlCol="0" anchor="ctr"/>
-          <a:lstStyle/>
-          <a:p>
-            <a:pPr algn="ctr"/>
-            <a:endParaRPr lang="ko-KR" altLang="en-US"/>
-          </a:p>
-        </p:txBody>
-      </p:sp>
-    </p:spTree>
-    <p:extLst>
-      <p:ext uri="{BB962C8B-B14F-4D97-AF65-F5344CB8AC3E}">
-        <p14:creationId xmlns:p14="http://schemas.microsoft.com/office/powerpoint/2010/main" val="589975460"/>
-      </p:ext>
-    </p:extLst>
-  </p:cSld>
-  <p:clrMapOvr>
-    <a:masterClrMapping/>
-  </p:clrMapOvr>
-</p:sld>
-</file>
-
-<file path=ppt/slides/slide3.xml><?xml version="1.0" encoding="utf-8"?>
-<p:sld xmlns:a="http://schemas.openxmlformats.org/drawingml/2006/main" xmlns:r="http://schemas.openxmlformats.org/officeDocument/2006/relationships" xmlns:p="http://schemas.openxmlformats.org/presentationml/2006/main">
-  <p:cSld>
-    <p:spTree>
-      <p:nvGrpSpPr>
-        <p:cNvPr id="1" name=""/>
-        <p:cNvGrpSpPr/>
-        <p:nvPr/>
-      </p:nvGrpSpPr>
-      <p:grpSpPr>
-        <a:xfrm>
-          <a:off x="0" y="0"/>
-          <a:ext cx="0" cy="0"/>
-          <a:chOff x="0" y="0"/>
-          <a:chExt cx="0" cy="0"/>
-        </a:xfrm>
-      </p:grpSpPr>
-      <p:sp>
-        <p:nvSpPr>
-          <p:cNvPr id="12" name="직사각형 11"/>
-          <p:cNvSpPr/>
-          <p:nvPr/>
-        </p:nvSpPr>
-        <p:spPr>
-          <a:xfrm>
-            <a:off x="409575" y="866775"/>
-            <a:ext cx="10810875" cy="5391150"/>
-          </a:xfrm>
-          <a:prstGeom prst="rect">
-            <a:avLst/>
-          </a:prstGeom>
-          <a:solidFill>
-            <a:schemeClr val="bg2"/>
-          </a:solidFill>
-        </p:spPr>
-        <p:style>
-          <a:lnRef idx="2">
-            <a:schemeClr val="accent1">
-              <a:shade val="50000"/>
-            </a:schemeClr>
-          </a:lnRef>
-          <a:fillRef idx="1">
-            <a:schemeClr val="accent1"/>
-          </a:fillRef>
-          <a:effectRef idx="0">
-            <a:schemeClr val="accent1"/>
-          </a:effectRef>
-          <a:fontRef idx="minor">
-            <a:schemeClr val="lt1"/>
-          </a:fontRef>
-        </p:style>
-        <p:txBody>
-          <a:bodyPr rtlCol="0" anchor="ctr"/>
-          <a:lstStyle/>
-          <a:p>
-            <a:pPr algn="ctr"/>
-            <a:endParaRPr lang="ko-KR" altLang="en-US"/>
-          </a:p>
-        </p:txBody>
-      </p:sp>
-      <p:sp>
-        <p:nvSpPr>
-          <p:cNvPr id="7" name="직사각형 6"/>
-          <p:cNvSpPr/>
-          <p:nvPr/>
-        </p:nvSpPr>
-        <p:spPr>
-          <a:xfrm>
-            <a:off x="571500" y="971550"/>
-            <a:ext cx="1028700" cy="234007"/>
-          </a:xfrm>
-          <a:prstGeom prst="rect">
-            <a:avLst/>
-          </a:prstGeom>
-        </p:spPr>
-        <p:style>
-          <a:lnRef idx="2">
-            <a:schemeClr val="accent1">
-              <a:shade val="50000"/>
-            </a:schemeClr>
-          </a:lnRef>
-          <a:fillRef idx="1">
-            <a:schemeClr val="accent1"/>
-          </a:fillRef>
-          <a:effectRef idx="0">
-            <a:schemeClr val="accent1"/>
-          </a:effectRef>
-          <a:fontRef idx="minor">
-            <a:schemeClr val="lt1"/>
-          </a:fontRef>
-        </p:style>
-        <p:txBody>
-          <a:bodyPr rtlCol="0" anchor="ctr"/>
-          <a:lstStyle/>
-          <a:p>
-            <a:pPr algn="ctr"/>
-            <a:endParaRPr lang="ko-KR" altLang="en-US"/>
-          </a:p>
-        </p:txBody>
-      </p:sp>
-      <p:sp>
-        <p:nvSpPr>
-          <p:cNvPr id="8" name="직사각형 7"/>
-          <p:cNvSpPr/>
-          <p:nvPr/>
-        </p:nvSpPr>
-        <p:spPr>
-          <a:xfrm>
-            <a:off x="1704975" y="971550"/>
-            <a:ext cx="1028700" cy="234007"/>
-          </a:xfrm>
-          <a:prstGeom prst="rect">
-            <a:avLst/>
-          </a:prstGeom>
-        </p:spPr>
-        <p:style>
-          <a:lnRef idx="2">
-            <a:schemeClr val="accent1">
-              <a:shade val="50000"/>
-            </a:schemeClr>
-          </a:lnRef>
-          <a:fillRef idx="1">
-            <a:schemeClr val="accent1"/>
-          </a:fillRef>
-          <a:effectRef idx="0">
-            <a:schemeClr val="accent1"/>
-          </a:effectRef>
-          <a:fontRef idx="minor">
-            <a:schemeClr val="lt1"/>
-          </a:fontRef>
-        </p:style>
-        <p:txBody>
-          <a:bodyPr rtlCol="0" anchor="ctr"/>
-          <a:lstStyle/>
-          <a:p>
-            <a:pPr algn="ctr"/>
-            <a:endParaRPr lang="ko-KR" altLang="en-US"/>
-          </a:p>
-        </p:txBody>
-      </p:sp>
-      <p:sp>
-        <p:nvSpPr>
-          <p:cNvPr id="18" name="직사각형 17"/>
-          <p:cNvSpPr/>
-          <p:nvPr/>
-        </p:nvSpPr>
-        <p:spPr>
-          <a:xfrm>
-            <a:off x="571501" y="1310332"/>
-            <a:ext cx="10487024" cy="4790430"/>
-          </a:xfrm>
-          <a:prstGeom prst="rect">
-            <a:avLst/>
-          </a:prstGeom>
-        </p:spPr>
-        <p:style>
-          <a:lnRef idx="2">
-            <a:schemeClr val="accent1">
-              <a:shade val="50000"/>
-            </a:schemeClr>
-          </a:lnRef>
-          <a:fillRef idx="1">
-            <a:schemeClr val="accent1"/>
-          </a:fillRef>
-          <a:effectRef idx="0">
-            <a:schemeClr val="accent1"/>
-          </a:effectRef>
-          <a:fontRef idx="minor">
-            <a:schemeClr val="lt1"/>
-          </a:fontRef>
-        </p:style>
-        <p:txBody>
-          <a:bodyPr rtlCol="0" anchor="ctr"/>
-          <a:lstStyle/>
-          <a:p>
-            <a:pPr algn="ctr"/>
-            <a:endParaRPr lang="ko-KR" altLang="en-US"/>
-          </a:p>
-        </p:txBody>
-      </p:sp>
-      <p:sp>
-        <p:nvSpPr>
-          <p:cNvPr id="11" name="직사각형 10"/>
-          <p:cNvSpPr/>
-          <p:nvPr/>
-        </p:nvSpPr>
-        <p:spPr>
-          <a:xfrm>
-            <a:off x="758741" y="1468892"/>
-            <a:ext cx="5056271" cy="1338477"/>
-          </a:xfrm>
-          <a:prstGeom prst="rect">
-            <a:avLst/>
-          </a:prstGeom>
-          <a:solidFill>
-            <a:schemeClr val="tx2">
-              <a:lumMod val="20000"/>
-              <a:lumOff val="80000"/>
-            </a:schemeClr>
-          </a:solidFill>
-        </p:spPr>
-        <p:style>
-          <a:lnRef idx="2">
-            <a:schemeClr val="accent1">
-              <a:shade val="50000"/>
-            </a:schemeClr>
-          </a:lnRef>
-          <a:fillRef idx="1">
-            <a:schemeClr val="accent1"/>
-          </a:fillRef>
-          <a:effectRef idx="0">
-            <a:schemeClr val="accent1"/>
-          </a:effectRef>
-          <a:fontRef idx="minor">
-            <a:schemeClr val="lt1"/>
-          </a:fontRef>
-        </p:style>
-        <p:txBody>
-          <a:bodyPr rtlCol="0" anchor="ctr"/>
-          <a:lstStyle/>
-          <a:p>
-            <a:pPr algn="ctr"/>
-            <a:endParaRPr lang="ko-KR" altLang="en-US"/>
-          </a:p>
-        </p:txBody>
-      </p:sp>
-      <p:sp>
-        <p:nvSpPr>
-          <p:cNvPr id="13" name="직사각형 12"/>
-          <p:cNvSpPr/>
-          <p:nvPr/>
-        </p:nvSpPr>
-        <p:spPr>
-          <a:xfrm>
-            <a:off x="758740" y="2965929"/>
-            <a:ext cx="5056271" cy="1338477"/>
-          </a:xfrm>
-          <a:prstGeom prst="rect">
-            <a:avLst/>
-          </a:prstGeom>
-          <a:solidFill>
-            <a:schemeClr val="tx2">
-              <a:lumMod val="20000"/>
-              <a:lumOff val="80000"/>
-            </a:schemeClr>
-          </a:solidFill>
-        </p:spPr>
-        <p:style>
-          <a:lnRef idx="2">
-            <a:schemeClr val="accent1">
-              <a:shade val="50000"/>
-            </a:schemeClr>
-          </a:lnRef>
-          <a:fillRef idx="1">
-            <a:schemeClr val="accent1"/>
-          </a:fillRef>
-          <a:effectRef idx="0">
-            <a:schemeClr val="accent1"/>
-          </a:effectRef>
-          <a:fontRef idx="minor">
-            <a:schemeClr val="lt1"/>
-          </a:fontRef>
-        </p:style>
-        <p:txBody>
-          <a:bodyPr rtlCol="0" anchor="ctr"/>
-          <a:lstStyle/>
-          <a:p>
-            <a:pPr algn="ctr"/>
-            <a:endParaRPr lang="ko-KR" altLang="en-US"/>
-          </a:p>
-        </p:txBody>
-      </p:sp>
-    </p:spTree>
-    <p:extLst>
-      <p:ext uri="{BB962C8B-B14F-4D97-AF65-F5344CB8AC3E}">
-        <p14:creationId xmlns:p14="http://schemas.microsoft.com/office/powerpoint/2010/main" val="2571391398"/>
+        <p14:creationId xmlns:p14="http://schemas.microsoft.com/office/powerpoint/2010/main" val="3045867094"/>
       </p:ext>
     </p:extLst>
   </p:cSld>

</xml_diff>